<commit_message>
Update HW2 handwriting notebook and presentation
</commit_message>
<xml_diff>
--- a/hw2_handwriting 簡報.pptx
+++ b/hw2_handwriting 簡報.pptx
@@ -1889,7 +1889,7 @@
           <p:nvPr>
             <p:extLst>
               <p:ext uri="{D42A27DB-BD31-4B8C-83A1-F6EECF244321}">
-                <p14:modId xmlns:p14="http://schemas.microsoft.com/office/powerpoint/2010/main" val="1579011935"/>
+                <p14:modId xmlns:p14="http://schemas.microsoft.com/office/powerpoint/2010/main" val="1713006409"/>
               </p:ext>
             </p:extLst>
           </p:nvPr>
@@ -2356,7 +2356,29 @@
                           <a:ea typeface="Calibri" pitchFamily="34" charset="-122"/>
                           <a:cs typeface="Calibri" pitchFamily="34" charset="-120"/>
                         </a:rPr>
-                        <a:t>SVD (k=10)</a:t>
+                        <a:t>SVD (k=1</a:t>
+                      </a:r>
+                      <a:r>
+                        <a:rPr lang="en-US" altLang="zh-TW" sz="1100" dirty="0">
+                          <a:solidFill>
+                            <a:srgbClr val="0F172A"/>
+                          </a:solidFill>
+                          <a:latin typeface="Calibri" pitchFamily="34" charset="0"/>
+                          <a:ea typeface="Calibri" pitchFamily="34" charset="-122"/>
+                          <a:cs typeface="Calibri" pitchFamily="34" charset="-120"/>
+                        </a:rPr>
+                        <a:t>2</a:t>
+                      </a:r>
+                      <a:r>
+                        <a:rPr lang="en-US" sz="1100" dirty="0">
+                          <a:solidFill>
+                            <a:srgbClr val="0F172A"/>
+                          </a:solidFill>
+                          <a:latin typeface="Calibri" pitchFamily="34" charset="0"/>
+                          <a:ea typeface="Calibri" pitchFamily="34" charset="-122"/>
+                          <a:cs typeface="Calibri" pitchFamily="34" charset="-120"/>
+                        </a:rPr>
+                        <a:t>)</a:t>
                       </a:r>
                       <a:endParaRPr lang="en-US" sz="1100" dirty="0">
                         <a:latin typeface="Calibri" charset="0"/>
@@ -2421,7 +2443,7 @@
                           <a:ea typeface="Calibri" pitchFamily="34" charset="-122"/>
                           <a:cs typeface="Calibri" pitchFamily="34" charset="-120"/>
                         </a:rPr>
-                        <a:t>0.934</a:t>
+                        <a:t>0.945</a:t>
                       </a:r>
                       <a:endParaRPr lang="en-US" sz="1100" dirty="0">
                         <a:latin typeface="Calibri" charset="0"/>
@@ -2474,25 +2496,20 @@
                     <a:bodyPr/>
                     <a:lstStyle/>
                     <a:p>
-                      <a:pPr marL="0" indent="0" algn="ctr">
+                      <a:pPr marL="0" indent="0" algn="ctr" defTabSz="914400" rtl="0" eaLnBrk="1" latinLnBrk="0" hangingPunct="1">
                         <a:buNone/>
                       </a:pPr>
                       <a:r>
-                        <a:rPr lang="en-US" sz="1100" dirty="0">
+                        <a:rPr lang="en-US" sz="1100" b="1" kern="1200" dirty="0">
                           <a:solidFill>
-                            <a:srgbClr val="0F172A"/>
+                            <a:srgbClr val="0D9488"/>
                           </a:solidFill>
                           <a:latin typeface="Calibri" pitchFamily="34" charset="0"/>
                           <a:ea typeface="Calibri" pitchFamily="34" charset="-122"/>
                           <a:cs typeface="Calibri" pitchFamily="34" charset="-120"/>
                         </a:rPr>
-                        <a:t>0.40</a:t>
+                        <a:t>0.80</a:t>
                       </a:r>
-                      <a:endParaRPr lang="en-US" sz="1100" dirty="0">
-                        <a:latin typeface="Calibri" charset="0"/>
-                        <a:ea typeface="Calibri" charset="0"/>
-                        <a:cs typeface="Calibri" charset="0"/>
-                      </a:endParaRPr>
                     </a:p>
                   </a:txBody>
                   <a:tcPr marL="101600" marR="101600" marT="38100" marB="38100" anchor="ctr">
@@ -2558,7 +2575,29 @@
                           <a:ea typeface="Calibri" pitchFamily="34" charset="-122"/>
                           <a:cs typeface="Calibri" pitchFamily="34" charset="-120"/>
                         </a:rPr>
-                        <a:t>HOSVD (k=10)</a:t>
+                        <a:t>HOSVD (k=1</a:t>
+                      </a:r>
+                      <a:r>
+                        <a:rPr lang="en-US" altLang="zh-TW" sz="1100" dirty="0">
+                          <a:solidFill>
+                            <a:srgbClr val="0F172A"/>
+                          </a:solidFill>
+                          <a:latin typeface="Calibri" pitchFamily="34" charset="0"/>
+                          <a:ea typeface="Calibri" pitchFamily="34" charset="-122"/>
+                          <a:cs typeface="Calibri" pitchFamily="34" charset="-120"/>
+                        </a:rPr>
+                        <a:t>2</a:t>
+                      </a:r>
+                      <a:r>
+                        <a:rPr lang="en-US" sz="1100" dirty="0">
+                          <a:solidFill>
+                            <a:srgbClr val="0F172A"/>
+                          </a:solidFill>
+                          <a:latin typeface="Calibri" pitchFamily="34" charset="0"/>
+                          <a:ea typeface="Calibri" pitchFamily="34" charset="-122"/>
+                          <a:cs typeface="Calibri" pitchFamily="34" charset="-120"/>
+                        </a:rPr>
+                        <a:t>)</a:t>
                       </a:r>
                       <a:endParaRPr lang="en-US" sz="1100" dirty="0">
                         <a:latin typeface="Calibri" charset="0"/>
@@ -2623,7 +2662,7 @@
                           <a:ea typeface="Calibri" pitchFamily="34" charset="-122"/>
                           <a:cs typeface="Calibri" pitchFamily="34" charset="-120"/>
                         </a:rPr>
-                        <a:t>0.935</a:t>
+                        <a:t>0.945</a:t>
                       </a:r>
                       <a:endParaRPr lang="en-US" sz="1100" dirty="0">
                         <a:latin typeface="Calibri" charset="0"/>
@@ -2680,21 +2719,16 @@
                         <a:buNone/>
                       </a:pPr>
                       <a:r>
-                        <a:rPr lang="en-US" sz="1100" dirty="0">
+                        <a:rPr lang="en-US" sz="1100" b="1" kern="1200" dirty="0">
                           <a:solidFill>
-                            <a:srgbClr val="0F172A"/>
+                            <a:srgbClr val="0D9488"/>
                           </a:solidFill>
                           <a:latin typeface="Calibri" pitchFamily="34" charset="0"/>
                           <a:ea typeface="Calibri" pitchFamily="34" charset="-122"/>
                           <a:cs typeface="Calibri" pitchFamily="34" charset="-120"/>
                         </a:rPr>
-                        <a:t>0.40</a:t>
+                        <a:t>0.80</a:t>
                       </a:r>
-                      <a:endParaRPr lang="en-US" sz="1100" dirty="0">
-                        <a:latin typeface="Calibri" charset="0"/>
-                        <a:ea typeface="Calibri" charset="0"/>
-                        <a:cs typeface="Calibri" charset="0"/>
-                      </a:endParaRPr>
                     </a:p>
                   </a:txBody>
                   <a:tcPr marL="101600" marR="101600" marT="38100" marB="38100" anchor="ctr">
@@ -2825,7 +2859,7 @@
                           <a:ea typeface="Calibri" pitchFamily="34" charset="-122"/>
                           <a:cs typeface="Calibri" pitchFamily="34" charset="-120"/>
                         </a:rPr>
-                        <a:t>0.940</a:t>
+                        <a:t>0.942</a:t>
                       </a:r>
                       <a:endParaRPr lang="en-US" sz="1100" dirty="0">
                         <a:latin typeface="Calibri" charset="0"/>
@@ -2890,7 +2924,7 @@
                           <a:ea typeface="Calibri" pitchFamily="34" charset="-122"/>
                           <a:cs typeface="Calibri" pitchFamily="34" charset="-120"/>
                         </a:rPr>
-                        <a:t>0.50</a:t>
+                        <a:t>0.30</a:t>
                       </a:r>
                       <a:endParaRPr lang="en-US" sz="1100" dirty="0">
                         <a:latin typeface="Calibri" charset="0"/>
@@ -3027,7 +3061,7 @@
                           <a:ea typeface="Calibri" pitchFamily="34" charset="-122"/>
                           <a:cs typeface="Calibri" pitchFamily="34" charset="-120"/>
                         </a:rPr>
-                        <a:t>0.910</a:t>
+                        <a:t>0.940</a:t>
                       </a:r>
                       <a:endParaRPr lang="en-US" sz="1100" dirty="0">
                         <a:latin typeface="Calibri" charset="0"/>
@@ -3229,7 +3263,7 @@
                           <a:ea typeface="Calibri" pitchFamily="34" charset="-122"/>
                           <a:cs typeface="Calibri" pitchFamily="34" charset="-120"/>
                         </a:rPr>
-                        <a:t>0.961</a:t>
+                        <a:t>0.965</a:t>
                       </a:r>
                       <a:endParaRPr lang="en-US" sz="1100" dirty="0">
                         <a:latin typeface="Calibri" charset="0"/>
@@ -3294,7 +3328,7 @@
                           <a:ea typeface="Calibri" pitchFamily="34" charset="-122"/>
                           <a:cs typeface="Calibri" pitchFamily="34" charset="-120"/>
                         </a:rPr>
-                        <a:t>0.70</a:t>
+                        <a:t>0.80</a:t>
                       </a:r>
                       <a:endParaRPr lang="en-US" sz="1100" dirty="0">
                         <a:latin typeface="Calibri" charset="0"/>
@@ -3431,7 +3465,7 @@
                           <a:ea typeface="Calibri" pitchFamily="34" charset="-122"/>
                           <a:cs typeface="Calibri" pitchFamily="34" charset="-120"/>
                         </a:rPr>
-                        <a:t>0.880</a:t>
+                        <a:t>0.922</a:t>
                       </a:r>
                       <a:endParaRPr lang="en-US" sz="1100" dirty="0">
                         <a:latin typeface="Calibri" charset="0"/>
@@ -3496,7 +3530,7 @@
                           <a:ea typeface="Calibri" pitchFamily="34" charset="-122"/>
                           <a:cs typeface="Calibri" pitchFamily="34" charset="-120"/>
                         </a:rPr>
-                        <a:t>0.20</a:t>
+                        <a:t>0.10</a:t>
                       </a:r>
                       <a:endParaRPr lang="en-US" sz="1100" dirty="0">
                         <a:latin typeface="Calibri" charset="0"/>
@@ -3633,7 +3667,7 @@
                           <a:ea typeface="Calibri" pitchFamily="34" charset="-122"/>
                           <a:cs typeface="Calibri" pitchFamily="34" charset="-120"/>
                         </a:rPr>
-                        <a:t>0.920</a:t>
+                        <a:t>0.945</a:t>
                       </a:r>
                       <a:endParaRPr lang="en-US" sz="1100" dirty="0">
                         <a:latin typeface="Calibri" charset="0"/>
@@ -3698,7 +3732,7 @@
                           <a:ea typeface="Calibri" pitchFamily="34" charset="-122"/>
                           <a:cs typeface="Calibri" pitchFamily="34" charset="-120"/>
                         </a:rPr>
-                        <a:t>0.40</a:t>
+                        <a:t>0.30</a:t>
                       </a:r>
                       <a:endParaRPr lang="en-US" sz="1100" dirty="0">
                         <a:latin typeface="Calibri" charset="0"/>
@@ -3875,7 +3909,7 @@
                 <a:ea typeface="Calibri" pitchFamily="34" charset="-122"/>
                 <a:cs typeface="Calibri" pitchFamily="34" charset="-120"/>
               </a:rPr>
-              <a:t>70%</a:t>
+              <a:t>80%</a:t>
             </a:r>
             <a:endParaRPr lang="en-US" sz="3600" dirty="0"/>
           </a:p>
@@ -6761,7 +6795,7 @@
                 <a:ea typeface="Calibri" pitchFamily="34" charset="-122"/>
                 <a:cs typeface="Calibri" pitchFamily="34" charset="-120"/>
               </a:rPr>
-              <a:t>10.0</a:t>
+              <a:t>10</a:t>
             </a:r>
             <a:r>
               <a:rPr lang="en-US" sz="6000" b="1" dirty="0">
@@ -7083,8 +7117,8 @@
           </a:p>
         </p:txBody>
       </p:sp>
-      <mc:AlternateContent xmlns:mc="http://schemas.openxmlformats.org/markup-compatibility/2006">
-        <mc:Choice xmlns:a14="http://schemas.microsoft.com/office/drawing/2010/main" Requires="a14">
+      <mc:AlternateContent xmlns:mc="http://schemas.openxmlformats.org/markup-compatibility/2006" xmlns:a14="http://schemas.microsoft.com/office/drawing/2010/main">
+        <mc:Choice Requires="a14">
           <p:sp>
             <p:nvSpPr>
               <p:cNvPr id="8" name="Text 6"/>
@@ -7716,7 +7750,7 @@
             </p:txBody>
           </p:sp>
         </mc:Choice>
-        <mc:Fallback>
+        <mc:Fallback xmlns="">
           <p:sp>
             <p:nvSpPr>
               <p:cNvPr id="8" name="Text 6"/>
@@ -7847,7 +7881,7 @@
                 <a:ea typeface="Calibri" pitchFamily="34" charset="-122"/>
                 <a:cs typeface="Calibri" pitchFamily="34" charset="-120"/>
               </a:rPr>
-              <a:t>4.52</a:t>
+              <a:t>4.5</a:t>
             </a:r>
             <a:r>
               <a:rPr lang="en-US" sz="1800" b="1" dirty="0">
@@ -8422,8 +8456,8 @@
           </a:p>
         </p:txBody>
       </p:sp>
-      <mc:AlternateContent xmlns:mc="http://schemas.openxmlformats.org/markup-compatibility/2006">
-        <mc:Choice xmlns:a14="http://schemas.microsoft.com/office/drawing/2010/main" Requires="a14">
+      <mc:AlternateContent xmlns:mc="http://schemas.openxmlformats.org/markup-compatibility/2006" xmlns:a14="http://schemas.microsoft.com/office/drawing/2010/main">
+        <mc:Choice Requires="a14">
           <p:sp>
             <p:nvSpPr>
               <p:cNvPr id="11" name="Text 9"/>
@@ -8536,7 +8570,7 @@
             </p:txBody>
           </p:sp>
         </mc:Choice>
-        <mc:Fallback>
+        <mc:Fallback xmlns="">
           <p:sp>
             <p:nvSpPr>
               <p:cNvPr id="11" name="Text 9"/>
@@ -8665,8 +8699,8 @@
           </a:p>
         </p:txBody>
       </p:sp>
-      <mc:AlternateContent xmlns:mc="http://schemas.openxmlformats.org/markup-compatibility/2006">
-        <mc:Choice xmlns:a14="http://schemas.microsoft.com/office/drawing/2010/main" Requires="a14">
+      <mc:AlternateContent xmlns:mc="http://schemas.openxmlformats.org/markup-compatibility/2006" xmlns:a14="http://schemas.microsoft.com/office/drawing/2010/main">
+        <mc:Choice Requires="a14">
           <p:sp>
             <p:nvSpPr>
               <p:cNvPr id="15" name="Text 13"/>
@@ -8692,119 +8726,125 @@
                   <a:buNone/>
                 </a:pPr>
                 <a14:m>
-                  <m:oMath xmlns:m="http://schemas.openxmlformats.org/officeDocument/2006/math">
-                    <m:r>
-                      <a:rPr lang="en-US" sz="1200" b="1" i="1" dirty="0" smtClean="0">
-                        <a:solidFill>
-                          <a:srgbClr val="0F172A"/>
-                        </a:solidFill>
-                        <a:latin typeface="Cambria Math" panose="02040503050406030204" pitchFamily="18" charset="0"/>
-                        <a:ea typeface="Consolas" pitchFamily="34" charset="-122"/>
-                        <a:cs typeface="Consolas" pitchFamily="34" charset="-120"/>
-                      </a:rPr>
-                      <m:t>𝑭𝒋</m:t>
-                    </m:r>
-                    <m:r>
-                      <a:rPr lang="en-US" sz="1200" b="1" i="1" dirty="0" smtClean="0">
-                        <a:solidFill>
-                          <a:srgbClr val="0F172A"/>
-                        </a:solidFill>
-                        <a:latin typeface="Cambria Math" panose="02040503050406030204" pitchFamily="18" charset="0"/>
-                        <a:ea typeface="Consolas" pitchFamily="34" charset="-122"/>
-                        <a:cs typeface="Consolas" pitchFamily="34" charset="-120"/>
-                      </a:rPr>
-                      <m:t> = </m:t>
-                    </m:r>
-                    <m:r>
-                      <a:rPr lang="en-US" sz="1200" b="1" i="1" dirty="0" smtClean="0">
-                        <a:solidFill>
-                          <a:srgbClr val="0F172A"/>
-                        </a:solidFill>
-                        <a:latin typeface="Cambria Math" panose="02040503050406030204" pitchFamily="18" charset="0"/>
-                        <a:ea typeface="Consolas" pitchFamily="34" charset="-122"/>
-                        <a:cs typeface="Consolas" pitchFamily="34" charset="-120"/>
-                      </a:rPr>
-                      <m:t>𝑼</m:t>
-                    </m:r>
-                    <m:r>
-                      <a:rPr lang="en-US" sz="1200" b="1" i="1" dirty="0" smtClean="0">
-                        <a:solidFill>
-                          <a:srgbClr val="0F172A"/>
-                        </a:solidFill>
-                        <a:latin typeface="Cambria Math" panose="02040503050406030204" pitchFamily="18" charset="0"/>
-                        <a:ea typeface="Consolas" pitchFamily="34" charset="-122"/>
-                        <a:cs typeface="Consolas" pitchFamily="34" charset="-120"/>
-                      </a:rPr>
-                      <m:t>₁ · </m:t>
-                    </m:r>
-                    <m:r>
-                      <a:rPr lang="en-US" sz="1200" b="1" i="1" dirty="0" smtClean="0">
-                        <a:solidFill>
-                          <a:srgbClr val="0F172A"/>
-                        </a:solidFill>
-                        <a:latin typeface="Cambria Math" panose="02040503050406030204" pitchFamily="18" charset="0"/>
-                        <a:ea typeface="Consolas" pitchFamily="34" charset="-122"/>
-                        <a:cs typeface="Consolas" pitchFamily="34" charset="-120"/>
-                      </a:rPr>
-                      <m:t>𝑺</m:t>
-                    </m:r>
-                    <m:r>
-                      <a:rPr lang="en-US" sz="1200" b="1" i="1" dirty="0" smtClean="0">
-                        <a:solidFill>
-                          <a:srgbClr val="0F172A"/>
-                        </a:solidFill>
-                        <a:latin typeface="Cambria Math" panose="02040503050406030204" pitchFamily="18" charset="0"/>
-                        <a:ea typeface="Consolas" pitchFamily="34" charset="-122"/>
-                        <a:cs typeface="Consolas" pitchFamily="34" charset="-120"/>
-                      </a:rPr>
-                      <m:t>[:,:,</m:t>
-                    </m:r>
-                    <m:r>
-                      <a:rPr lang="en-US" sz="1200" b="1" i="1" dirty="0" smtClean="0">
-                        <a:solidFill>
-                          <a:srgbClr val="0F172A"/>
-                        </a:solidFill>
-                        <a:latin typeface="Cambria Math" panose="02040503050406030204" pitchFamily="18" charset="0"/>
-                        <a:ea typeface="Consolas" pitchFamily="34" charset="-122"/>
-                        <a:cs typeface="Consolas" pitchFamily="34" charset="-120"/>
-                      </a:rPr>
-                      <m:t>𝒋</m:t>
-                    </m:r>
-                    <m:r>
-                      <a:rPr lang="en-US" sz="1200" b="1" i="1" dirty="0" smtClean="0">
-                        <a:solidFill>
-                          <a:srgbClr val="0F172A"/>
-                        </a:solidFill>
-                        <a:latin typeface="Cambria Math" panose="02040503050406030204" pitchFamily="18" charset="0"/>
-                        <a:ea typeface="Consolas" pitchFamily="34" charset="-122"/>
-                        <a:cs typeface="Consolas" pitchFamily="34" charset="-120"/>
-                      </a:rPr>
-                      <m:t>] · </m:t>
-                    </m:r>
-                    <m:r>
-                      <a:rPr lang="en-US" sz="1200" b="1" i="1" dirty="0" smtClean="0">
-                        <a:solidFill>
-                          <a:srgbClr val="0F172A"/>
-                        </a:solidFill>
-                        <a:latin typeface="Cambria Math" panose="02040503050406030204" pitchFamily="18" charset="0"/>
-                        <a:ea typeface="Consolas" pitchFamily="34" charset="-122"/>
-                        <a:cs typeface="Consolas" pitchFamily="34" charset="-120"/>
-                      </a:rPr>
-                      <m:t>𝑼</m:t>
-                    </m:r>
-                    <m:r>
-                      <a:rPr lang="en-US" sz="1200" b="1" i="1" dirty="0" smtClean="0">
-                        <a:solidFill>
-                          <a:srgbClr val="0F172A"/>
-                        </a:solidFill>
-                        <a:latin typeface="Cambria Math" panose="02040503050406030204" pitchFamily="18" charset="0"/>
-                        <a:ea typeface="Consolas" pitchFamily="34" charset="-122"/>
-                        <a:cs typeface="Consolas" pitchFamily="34" charset="-120"/>
-                      </a:rPr>
-                      <m:t>₂ᵀ</m:t>
-                    </m:r>
-                  </m:oMath>
+                  <m:oMathPara xmlns:m="http://schemas.openxmlformats.org/officeDocument/2006/math">
+                    <m:oMathParaPr>
+                      <m:jc m:val="centerGroup"/>
+                    </m:oMathParaPr>
+                    <m:oMath xmlns:m="http://schemas.openxmlformats.org/officeDocument/2006/math">
+                      <m:r>
+                        <a:rPr lang="en-US" sz="1200" b="1" i="1" dirty="0" smtClean="0">
+                          <a:solidFill>
+                            <a:srgbClr val="0F172A"/>
+                          </a:solidFill>
+                          <a:latin typeface="Cambria Math" panose="02040503050406030204" pitchFamily="18" charset="0"/>
+                          <a:ea typeface="Consolas" pitchFamily="34" charset="-122"/>
+                          <a:cs typeface="Consolas" pitchFamily="34" charset="-120"/>
+                        </a:rPr>
+                        <m:t>𝑭𝒋</m:t>
+                      </m:r>
+                      <m:r>
+                        <a:rPr lang="en-US" sz="1200" b="1" i="1" dirty="0" smtClean="0">
+                          <a:solidFill>
+                            <a:srgbClr val="0F172A"/>
+                          </a:solidFill>
+                          <a:latin typeface="Cambria Math" panose="02040503050406030204" pitchFamily="18" charset="0"/>
+                          <a:ea typeface="Consolas" pitchFamily="34" charset="-122"/>
+                          <a:cs typeface="Consolas" pitchFamily="34" charset="-120"/>
+                        </a:rPr>
+                        <m:t> = </m:t>
+                      </m:r>
+                      <m:r>
+                        <a:rPr lang="en-US" sz="1200" b="1" i="1" dirty="0" smtClean="0">
+                          <a:solidFill>
+                            <a:srgbClr val="0F172A"/>
+                          </a:solidFill>
+                          <a:latin typeface="Cambria Math" panose="02040503050406030204" pitchFamily="18" charset="0"/>
+                          <a:ea typeface="Consolas" pitchFamily="34" charset="-122"/>
+                          <a:cs typeface="Consolas" pitchFamily="34" charset="-120"/>
+                        </a:rPr>
+                        <m:t>𝑼</m:t>
+                      </m:r>
+                      <m:r>
+                        <a:rPr lang="en-US" sz="1200" b="1" i="1" dirty="0" smtClean="0">
+                          <a:solidFill>
+                            <a:srgbClr val="0F172A"/>
+                          </a:solidFill>
+                          <a:latin typeface="Cambria Math" panose="02040503050406030204" pitchFamily="18" charset="0"/>
+                          <a:ea typeface="Consolas" pitchFamily="34" charset="-122"/>
+                          <a:cs typeface="Consolas" pitchFamily="34" charset="-120"/>
+                        </a:rPr>
+                        <m:t>₁ · </m:t>
+                      </m:r>
+                      <m:r>
+                        <a:rPr lang="en-US" sz="1200" b="1" i="1" dirty="0" smtClean="0">
+                          <a:solidFill>
+                            <a:srgbClr val="0F172A"/>
+                          </a:solidFill>
+                          <a:latin typeface="Cambria Math" panose="02040503050406030204" pitchFamily="18" charset="0"/>
+                          <a:ea typeface="Consolas" pitchFamily="34" charset="-122"/>
+                          <a:cs typeface="Consolas" pitchFamily="34" charset="-120"/>
+                        </a:rPr>
+                        <m:t>𝑺</m:t>
+                      </m:r>
+                      <m:r>
+                        <a:rPr lang="en-US" sz="1200" b="1" i="1" dirty="0" smtClean="0">
+                          <a:solidFill>
+                            <a:srgbClr val="0F172A"/>
+                          </a:solidFill>
+                          <a:latin typeface="Cambria Math" panose="02040503050406030204" pitchFamily="18" charset="0"/>
+                          <a:ea typeface="Consolas" pitchFamily="34" charset="-122"/>
+                          <a:cs typeface="Consolas" pitchFamily="34" charset="-120"/>
+                        </a:rPr>
+                        <m:t>[:,:,</m:t>
+                      </m:r>
+                      <m:r>
+                        <a:rPr lang="en-US" sz="1200" b="1" i="1" dirty="0" smtClean="0">
+                          <a:solidFill>
+                            <a:srgbClr val="0F172A"/>
+                          </a:solidFill>
+                          <a:latin typeface="Cambria Math" panose="02040503050406030204" pitchFamily="18" charset="0"/>
+                          <a:ea typeface="Consolas" pitchFamily="34" charset="-122"/>
+                          <a:cs typeface="Consolas" pitchFamily="34" charset="-120"/>
+                        </a:rPr>
+                        <m:t>𝒋</m:t>
+                      </m:r>
+                      <m:r>
+                        <a:rPr lang="en-US" sz="1200" b="1" i="1" dirty="0" smtClean="0">
+                          <a:solidFill>
+                            <a:srgbClr val="0F172A"/>
+                          </a:solidFill>
+                          <a:latin typeface="Cambria Math" panose="02040503050406030204" pitchFamily="18" charset="0"/>
+                          <a:ea typeface="Consolas" pitchFamily="34" charset="-122"/>
+                          <a:cs typeface="Consolas" pitchFamily="34" charset="-120"/>
+                        </a:rPr>
+                        <m:t>] · </m:t>
+                      </m:r>
+                      <m:r>
+                        <a:rPr lang="en-US" sz="1200" b="1" i="1" dirty="0" smtClean="0">
+                          <a:solidFill>
+                            <a:srgbClr val="0F172A"/>
+                          </a:solidFill>
+                          <a:latin typeface="Cambria Math" panose="02040503050406030204" pitchFamily="18" charset="0"/>
+                          <a:ea typeface="Consolas" pitchFamily="34" charset="-122"/>
+                          <a:cs typeface="Consolas" pitchFamily="34" charset="-120"/>
+                        </a:rPr>
+                        <m:t>𝑼</m:t>
+                      </m:r>
+                      <m:r>
+                        <a:rPr lang="en-US" sz="1200" b="1" i="1" dirty="0" smtClean="0">
+                          <a:solidFill>
+                            <a:srgbClr val="0F172A"/>
+                          </a:solidFill>
+                          <a:latin typeface="Cambria Math" panose="02040503050406030204" pitchFamily="18" charset="0"/>
+                          <a:ea typeface="Consolas" pitchFamily="34" charset="-122"/>
+                          <a:cs typeface="Consolas" pitchFamily="34" charset="-120"/>
+                        </a:rPr>
+                        <m:t>₂ᵀ</m:t>
+                      </m:r>
+                    </m:oMath>
+                  </m:oMathPara>
                 </a14:m>
+                <a:endParaRPr/>
               </a:p>
               <a:p>
                 <a:pPr marL="0" indent="0">
@@ -8826,7 +8866,7 @@
             </p:txBody>
           </p:sp>
         </mc:Choice>
-        <mc:Fallback>
+        <mc:Fallback xmlns="">
           <p:sp>
             <p:nvSpPr>
               <p:cNvPr id="15" name="Text 13"/>
@@ -8924,9 +8964,8 @@
                 <a:ea typeface="Calibri" pitchFamily="34" charset="-122"/>
                 <a:cs typeface="Calibri" pitchFamily="34" charset="-120"/>
               </a:rPr>
-              <a:t>USPS  ≈ 93.5%</a:t>
-            </a:r>
-            <a:endParaRPr lang="en-US" sz="1600" dirty="0"/>
+              <a:t>k=12  →  USPS 94.5%</a:t>
+            </a:r>
           </a:p>
         </p:txBody>
       </p:sp>
@@ -9397,7 +9436,7 @@
                 <a:ea typeface="Calibri" pitchFamily="34" charset="-122"/>
                 <a:cs typeface="Calibri" pitchFamily="34" charset="-120"/>
               </a:rPr>
-              <a:t>USPS 91%</a:t>
+              <a:t>USPS 94.0%</a:t>
             </a:r>
             <a:endParaRPr lang="en-US" sz="1100" dirty="0"/>
           </a:p>
@@ -9428,6 +9467,17 @@
               <a:buNone/>
             </a:pPr>
             <a:r>
+              <a:rPr lang="en-US" sz="1100" dirty="0" err="1">
+                <a:solidFill>
+                  <a:srgbClr val="475569"/>
+                </a:solidFill>
+                <a:latin typeface="Calibri" pitchFamily="34" charset="0"/>
+                <a:ea typeface="Calibri" pitchFamily="34" charset="-122"/>
+                <a:cs typeface="Calibri" pitchFamily="34" charset="-120"/>
+              </a:rPr>
+              <a:t>自寫</a:t>
+            </a:r>
+            <a:r>
               <a:rPr lang="en-US" sz="1100" dirty="0">
                 <a:solidFill>
                   <a:srgbClr val="475569"/>
@@ -9436,7 +9486,7 @@
                 <a:ea typeface="Calibri" pitchFamily="34" charset="-122"/>
                 <a:cs typeface="Calibri" pitchFamily="34" charset="-120"/>
               </a:rPr>
-              <a:t>自寫 60%</a:t>
+              <a:t> 60%</a:t>
             </a:r>
             <a:endParaRPr lang="en-US" sz="1100" dirty="0"/>
           </a:p>
@@ -9809,7 +9859,7 @@
                 <a:ea typeface="Calibri" pitchFamily="34" charset="-122"/>
                 <a:cs typeface="Calibri" pitchFamily="34" charset="-120"/>
               </a:rPr>
-              <a:t>USPS 96%</a:t>
+              <a:t>USPS 96.5%</a:t>
             </a:r>
             <a:endParaRPr lang="en-US" sz="1100" dirty="0"/>
           </a:p>
@@ -9840,6 +9890,17 @@
               <a:buNone/>
             </a:pPr>
             <a:r>
+              <a:rPr lang="en-US" sz="1100" b="1" dirty="0" err="1">
+                <a:solidFill>
+                  <a:srgbClr val="0D9488"/>
+                </a:solidFill>
+                <a:latin typeface="Calibri" pitchFamily="34" charset="0"/>
+                <a:ea typeface="Calibri" pitchFamily="34" charset="-122"/>
+                <a:cs typeface="Calibri" pitchFamily="34" charset="-120"/>
+              </a:rPr>
+              <a:t>自寫</a:t>
+            </a:r>
+            <a:r>
               <a:rPr lang="en-US" sz="1100" b="1" dirty="0">
                 <a:solidFill>
                   <a:srgbClr val="0D9488"/>
@@ -9848,7 +9909,7 @@
                 <a:ea typeface="Calibri" pitchFamily="34" charset="-122"/>
                 <a:cs typeface="Calibri" pitchFamily="34" charset="-120"/>
               </a:rPr>
-              <a:t>自寫 70%</a:t>
+              <a:t> 80%</a:t>
             </a:r>
             <a:endParaRPr lang="en-US" sz="1100" dirty="0"/>
           </a:p>
@@ -10157,7 +10218,7 @@
                 <a:ea typeface="Calibri" pitchFamily="34" charset="-122"/>
                 <a:cs typeface="Calibri" pitchFamily="34" charset="-120"/>
               </a:rPr>
-              <a:t>USPS 88%</a:t>
+              <a:t>USPS 92.2%</a:t>
             </a:r>
             <a:endParaRPr lang="en-US" sz="1100" dirty="0"/>
           </a:p>
@@ -10188,6 +10249,17 @@
               <a:buNone/>
             </a:pPr>
             <a:r>
+              <a:rPr lang="en-US" sz="1100" dirty="0" err="1">
+                <a:solidFill>
+                  <a:srgbClr val="475569"/>
+                </a:solidFill>
+                <a:latin typeface="Calibri" pitchFamily="34" charset="0"/>
+                <a:ea typeface="Calibri" pitchFamily="34" charset="-122"/>
+                <a:cs typeface="Calibri" pitchFamily="34" charset="-120"/>
+              </a:rPr>
+              <a:t>自寫</a:t>
+            </a:r>
+            <a:r>
               <a:rPr lang="en-US" sz="1100" dirty="0">
                 <a:solidFill>
                   <a:srgbClr val="475569"/>
@@ -10196,7 +10268,7 @@
                 <a:ea typeface="Calibri" pitchFamily="34" charset="-122"/>
                 <a:cs typeface="Calibri" pitchFamily="34" charset="-120"/>
               </a:rPr>
-              <a:t>自寫 20%</a:t>
+              <a:t> 10%</a:t>
             </a:r>
             <a:endParaRPr lang="en-US" sz="1100" dirty="0"/>
           </a:p>
@@ -10505,7 +10577,7 @@
                 <a:ea typeface="Calibri" pitchFamily="34" charset="-122"/>
                 <a:cs typeface="Calibri" pitchFamily="34" charset="-120"/>
               </a:rPr>
-              <a:t>USPS 92%</a:t>
+              <a:t>USPS 94.5%</a:t>
             </a:r>
             <a:endParaRPr lang="en-US" sz="1100" dirty="0"/>
           </a:p>
@@ -10536,6 +10608,17 @@
               <a:buNone/>
             </a:pPr>
             <a:r>
+              <a:rPr lang="en-US" sz="1100" dirty="0" err="1">
+                <a:solidFill>
+                  <a:srgbClr val="475569"/>
+                </a:solidFill>
+                <a:latin typeface="Calibri" pitchFamily="34" charset="0"/>
+                <a:ea typeface="Calibri" pitchFamily="34" charset="-122"/>
+                <a:cs typeface="Calibri" pitchFamily="34" charset="-120"/>
+              </a:rPr>
+              <a:t>自寫</a:t>
+            </a:r>
+            <a:r>
               <a:rPr lang="en-US" sz="1100" dirty="0">
                 <a:solidFill>
                   <a:srgbClr val="475569"/>
@@ -10544,7 +10627,7 @@
                 <a:ea typeface="Calibri" pitchFamily="34" charset="-122"/>
                 <a:cs typeface="Calibri" pitchFamily="34" charset="-120"/>
               </a:rPr>
-              <a:t>自寫 40%</a:t>
+              <a:t> 30%</a:t>
             </a:r>
             <a:endParaRPr lang="en-US" sz="1100" dirty="0"/>
           </a:p>
@@ -11040,7 +11123,7 @@
                 <a:ea typeface="Calibri" pitchFamily="34" charset="-122"/>
                 <a:cs typeface="Calibri" pitchFamily="34" charset="-120"/>
               </a:rPr>
-              <a:t>91%</a:t>
+              <a:t>94.0%</a:t>
             </a:r>
             <a:endParaRPr lang="en-US" sz="3200" dirty="0"/>
           </a:p>
@@ -11529,7 +11612,7 @@
                 <a:ea typeface="Calibri" pitchFamily="34" charset="-122"/>
                 <a:cs typeface="Calibri" pitchFamily="34" charset="-120"/>
               </a:rPr>
-              <a:t>96.1%</a:t>
+              <a:t>96.5%</a:t>
             </a:r>
             <a:endParaRPr lang="en-US" sz="2800" dirty="0"/>
           </a:p>
@@ -11632,7 +11715,7 @@
                 <a:ea typeface="Calibri" pitchFamily="34" charset="-122"/>
                 <a:cs typeface="Calibri" pitchFamily="34" charset="-120"/>
               </a:rPr>
-              <a:t>70%</a:t>
+              <a:t>80%</a:t>
             </a:r>
             <a:endParaRPr lang="en-US" sz="3200" dirty="0"/>
           </a:p>
@@ -12723,7 +12806,7 @@
                   <a:srgbClr val="EF4444"/>
                 </a:solidFill>
               </a:rPr>
-              <a:t>88%</a:t>
+              <a:t>92.2%</a:t>
             </a:r>
             <a:endParaRPr lang="en-US" sz="1600" dirty="0"/>
           </a:p>
@@ -12823,7 +12906,7 @@
                   <a:srgbClr val="FFFFFF"/>
                 </a:solidFill>
               </a:rPr>
-              <a:t>20%</a:t>
+              <a:t>10%</a:t>
             </a:r>
             <a:endParaRPr lang="en-US" sz="1600" dirty="0"/>
           </a:p>
@@ -13129,7 +13212,7 @@
                   <a:srgbClr val="F59E0B"/>
                 </a:solidFill>
               </a:rPr>
-              <a:t>92%</a:t>
+              <a:t>94.5%</a:t>
             </a:r>
             <a:endParaRPr lang="en-US" sz="1600" dirty="0"/>
           </a:p>
@@ -13229,7 +13312,7 @@
                   <a:srgbClr val="FFFFFF"/>
                 </a:solidFill>
               </a:rPr>
-              <a:t>40%</a:t>
+              <a:t>30%</a:t>
             </a:r>
             <a:endParaRPr lang="en-US" sz="1600" dirty="0"/>
           </a:p>

</xml_diff>

<commit_message>
Update HW2 handwriting presentation
</commit_message>
<xml_diff>
--- a/hw2_handwriting 簡報.pptx
+++ b/hw2_handwriting 簡報.pptx
@@ -1889,7 +1889,7 @@
           <p:nvPr>
             <p:extLst>
               <p:ext uri="{D42A27DB-BD31-4B8C-83A1-F6EECF244321}">
-                <p14:modId xmlns:p14="http://schemas.microsoft.com/office/powerpoint/2010/main" val="1713006409"/>
+                <p14:modId xmlns:p14="http://schemas.microsoft.com/office/powerpoint/2010/main" val="123656233"/>
               </p:ext>
             </p:extLst>
           </p:nvPr>
@@ -2207,13 +2207,13 @@
                     <a:bodyPr/>
                     <a:lstStyle/>
                     <a:p>
-                      <a:pPr marL="0" indent="0" algn="ctr">
+                      <a:pPr marL="0" indent="0" algn="ctr" defTabSz="914400" rtl="0" eaLnBrk="1" latinLnBrk="0" hangingPunct="1">
                         <a:buNone/>
                       </a:pPr>
                       <a:r>
-                        <a:rPr lang="en-US" sz="1100" dirty="0">
+                        <a:rPr lang="en-US" sz="1100" kern="1200" dirty="0">
                           <a:solidFill>
-                            <a:srgbClr val="0F172A"/>
+                            <a:srgbClr val="EF4444"/>
                           </a:solidFill>
                           <a:latin typeface="Calibri" pitchFamily="34" charset="0"/>
                           <a:ea typeface="Calibri" pitchFamily="34" charset="-122"/>
@@ -2221,11 +2221,6 @@
                         </a:rPr>
                         <a:t>0.814</a:t>
                       </a:r>
-                      <a:endParaRPr lang="en-US" sz="1100" dirty="0">
-                        <a:latin typeface="Calibri" charset="0"/>
-                        <a:ea typeface="Calibri" charset="0"/>
-                        <a:cs typeface="Calibri" charset="0"/>
-                      </a:endParaRPr>
                     </a:p>
                   </a:txBody>
                   <a:tcPr marL="101600" marR="101600" marT="38100" marB="38100" anchor="ctr">
@@ -3887,7 +3882,7 @@
                 <a:ea typeface="Calibri" pitchFamily="34" charset="-122"/>
                 <a:cs typeface="Calibri" pitchFamily="34" charset="-120"/>
               </a:rPr>
-              <a:t>96%</a:t>
+              <a:t>96.5%</a:t>
             </a:r>
             <a:r>
               <a:rPr lang="en-US" sz="2200" dirty="0">
@@ -4082,6 +4077,17 @@
               <a:t>1. </a:t>
             </a:r>
             <a:r>
+              <a:rPr lang="en-US" sz="1100" b="1" dirty="0" err="1">
+                <a:solidFill>
+                  <a:srgbClr val="0F172A"/>
+                </a:solidFill>
+                <a:latin typeface="Calibri" pitchFamily="34" charset="0"/>
+                <a:ea typeface="Calibri" pitchFamily="34" charset="-122"/>
+                <a:cs typeface="Calibri" pitchFamily="34" charset="-120"/>
+              </a:rPr>
+              <a:t>空間模型</a:t>
+            </a:r>
+            <a:r>
               <a:rPr lang="en-US" sz="1100" b="1" dirty="0">
                 <a:solidFill>
                   <a:srgbClr val="0F172A"/>
@@ -4090,7 +4096,7 @@
                 <a:ea typeface="Calibri" pitchFamily="34" charset="-122"/>
                 <a:cs typeface="Calibri" pitchFamily="34" charset="-120"/>
               </a:rPr>
-              <a:t>空間模型 (CNN) </a:t>
+              <a:t> (CNN) </a:t>
             </a:r>
             <a:r>
               <a:rPr lang="en-US" sz="1100" dirty="0">
@@ -4136,14 +4142,12 @@
               </a:rPr>
               <a:t>。</a:t>
             </a:r>
-            <a:endParaRPr lang="en-US" sz="1100" dirty="0"/>
-          </a:p>
-          <a:p>
-            <a:pPr marL="0" indent="0">
+          </a:p>
+          <a:p>
+            <a:pPr>
               <a:spcAft>
                 <a:spcPts val="400"/>
               </a:spcAft>
-              <a:buNone/>
             </a:pPr>
             <a:r>
               <a:rPr lang="en-US" sz="1100" b="1" dirty="0">
@@ -4157,7 +4161,7 @@
               <a:t>2. </a:t>
             </a:r>
             <a:r>
-              <a:rPr lang="en-US" sz="1100" b="1" dirty="0">
+              <a:rPr lang="en-US" altLang="zh-TW" sz="1100" b="1" dirty="0" err="1">
                 <a:solidFill>
                   <a:srgbClr val="0F172A"/>
                 </a:solidFill>
@@ -4165,7 +4169,62 @@
                 <a:ea typeface="Calibri" pitchFamily="34" charset="-122"/>
                 <a:cs typeface="Calibri" pitchFamily="34" charset="-120"/>
               </a:rPr>
-              <a:t>訓練資料分佈 </a:t>
+              <a:t>訓練資料分佈</a:t>
+            </a:r>
+            <a:r>
+              <a:rPr lang="en-US" altLang="zh-TW" sz="1100" b="1" dirty="0">
+                <a:solidFill>
+                  <a:srgbClr val="0F172A"/>
+                </a:solidFill>
+                <a:latin typeface="Calibri" pitchFamily="34" charset="0"/>
+                <a:ea typeface="Calibri" pitchFamily="34" charset="-122"/>
+                <a:cs typeface="Calibri" pitchFamily="34" charset="-120"/>
+              </a:rPr>
+              <a:t> </a:t>
+            </a:r>
+            <a:r>
+              <a:rPr lang="en-US" altLang="zh-TW" sz="1100" dirty="0" err="1">
+                <a:solidFill>
+                  <a:srgbClr val="0F172A"/>
+                </a:solidFill>
+                <a:latin typeface="Calibri" pitchFamily="34" charset="0"/>
+                <a:ea typeface="Calibri" pitchFamily="34" charset="-122"/>
+                <a:cs typeface="Calibri" pitchFamily="34" charset="-120"/>
+              </a:rPr>
+              <a:t>貼近真實場景</a:t>
+            </a:r>
+            <a:r>
+              <a:rPr lang="zh-TW" altLang="en-US" sz="1100">
+                <a:solidFill>
+                  <a:srgbClr val="0F172A"/>
+                </a:solidFill>
+                <a:latin typeface="Calibri" pitchFamily="34" charset="0"/>
+                <a:ea typeface="Calibri" pitchFamily="34" charset="-122"/>
+                <a:cs typeface="Calibri" pitchFamily="34" charset="-120"/>
+              </a:rPr>
+              <a:t>也是重要</a:t>
+            </a:r>
+            <a:r>
+              <a:rPr lang="en-US" altLang="zh-TW" sz="1100">
+                <a:solidFill>
+                  <a:srgbClr val="0F172A"/>
+                </a:solidFill>
+                <a:latin typeface="Calibri" pitchFamily="34" charset="0"/>
+                <a:ea typeface="Calibri" pitchFamily="34" charset="-122"/>
+                <a:cs typeface="Calibri" pitchFamily="34" charset="-120"/>
+              </a:rPr>
+              <a:t>關鍵</a:t>
+            </a:r>
+            <a:r>
+              <a:rPr lang="en-US" altLang="zh-TW" sz="1100" dirty="0">
+                <a:solidFill>
+                  <a:srgbClr val="0F172A"/>
+                </a:solidFill>
+                <a:latin typeface="Calibri" pitchFamily="34" charset="0"/>
+                <a:ea typeface="Calibri" pitchFamily="34" charset="-122"/>
+                <a:cs typeface="Calibri" pitchFamily="34" charset="-120"/>
+              </a:rPr>
+              <a:t> </a:t>
             </a:r>
             <a:r>
               <a:rPr lang="en-US" sz="1100" dirty="0">
@@ -4176,7 +4235,7 @@
                 <a:ea typeface="Calibri" pitchFamily="34" charset="-122"/>
                 <a:cs typeface="Calibri" pitchFamily="34" charset="-120"/>
               </a:rPr>
-              <a:t>貼近真實場景 比模型多深更關鍵。</a:t>
+              <a:t>。</a:t>
             </a:r>
             <a:endParaRPr lang="en-US" sz="1100" dirty="0"/>
           </a:p>

</xml_diff>